<commit_message>
chore: replace old pptx with updated openai/gpt-oss-20b presentation
</commit_message>
<xml_diff>
--- a/presentation/IT_Support_Agent_Presentation.pptx
+++ b/presentation/IT_Support_Agent_Presentation.pptx
@@ -3378,7 +3378,7 @@
               </a:defRPr>
             </a:pPr>
             <a:r>
-              <a:t>LangGraph state machine, Groq Llama 3.3 70B, FastAPI, and React.</a:t>
+              <a:t>LangGraph state machine, Groq (openai/gpt-oss-20b), FastAPI, and React.</a:t>
             </a:r>
           </a:p>
         </p:txBody>
@@ -7190,7 +7190,7 @@
               </a:defRPr>
             </a:pPr>
             <a:r>
-              <a:t>Groq API with llama-3.3-70b-versatile. Sub-second latency, temperature=0 for zero hallucination.</a:t>
+              <a:t>Groq API with openai/gpt-oss-20b. Sub-second latency, temperature=0 for zero hallucination.</a:t>
             </a:r>
           </a:p>
         </p:txBody>

</xml_diff>